<commit_message>
Added the Project Presentation
</commit_message>
<xml_diff>
--- a/slides/Presentation2.pptx
+++ b/slides/Presentation2.pptx
@@ -3427,7 +3427,10 @@
               <a:buChar char="Ø"/>
             </a:pPr>
             <a:r>
-              <a:rPr lang="en-IN" b="1" i="1" dirty="0"/>
+              <a:rPr lang="en-IN" b="1" i="1" dirty="0">
+                <a:latin typeface="Times New Roman" panose="02020603050405020304" pitchFamily="18" charset="0"/>
+                <a:cs typeface="Times New Roman" panose="02020603050405020304" pitchFamily="18" charset="0"/>
+              </a:rPr>
               <a:t>Student Name: </a:t>
             </a:r>
             <a:r>
@@ -3753,7 +3756,7 @@
         </p:blipFill>
         <p:spPr>
           <a:xfrm>
-            <a:off x="2129399" y="1856204"/>
+            <a:off x="2216863" y="1820907"/>
             <a:ext cx="7376607" cy="3659588"/>
           </a:xfrm>
           <a:prstGeom prst="rect">
@@ -4122,7 +4125,7 @@
         </p:blipFill>
         <p:spPr>
           <a:xfrm>
-            <a:off x="8023771" y="2825957"/>
+            <a:off x="8628070" y="2992934"/>
             <a:ext cx="2861565" cy="2060659"/>
           </a:xfrm>
           <a:prstGeom prst="rect">
@@ -4130,6 +4133,41 @@
           </a:prstGeom>
         </p:spPr>
       </p:pic>
+      <p:sp>
+        <p:nvSpPr>
+          <p:cNvPr id="8" name="TextBox 7">
+            <a:extLst>
+              <a:ext uri="{FF2B5EF4-FFF2-40B4-BE49-F238E27FC236}">
+                <a16:creationId xmlns:a16="http://schemas.microsoft.com/office/drawing/2014/main" id="{64A7A247-1106-98D9-D157-2934B38E92C1}"/>
+              </a:ext>
+            </a:extLst>
+          </p:cNvPr>
+          <p:cNvSpPr txBox="1"/>
+          <p:nvPr/>
+        </p:nvSpPr>
+        <p:spPr>
+          <a:xfrm>
+            <a:off x="8846278" y="5152446"/>
+            <a:ext cx="2568272" cy="369332"/>
+          </a:xfrm>
+          <a:prstGeom prst="rect">
+            <a:avLst/>
+          </a:prstGeom>
+          <a:noFill/>
+        </p:spPr>
+        <p:txBody>
+          <a:bodyPr wrap="square" rtlCol="0">
+            <a:spAutoFit/>
+          </a:bodyPr>
+          <a:lstStyle/>
+          <a:p>
+            <a:r>
+              <a:rPr lang="en-IN" dirty="0"/>
+              <a:t>(Project Folder Structure)</a:t>
+            </a:r>
+          </a:p>
+        </p:txBody>
+      </p:sp>
     </p:spTree>
     <p:extLst>
       <p:ext uri="{BB962C8B-B14F-4D97-AF65-F5344CB8AC3E}">

</xml_diff>